<commit_message>
Lesson 6: name the sensor pin the way the board prints it
The board has no pin marked IO36. GPIO36 is silk-screened SENSOR VP, so
that is what the wiring diagram, the file headers and the README now say.
The code still calls ADC(Pin(36)), which is the chip's name for the same
pin, without explaining itself to students.

Also on the wiring slide: the module photo with its S, V, G header, and a
note to leave the ultrasonic sensor, buzzer and servo in the box today.
</commit_message>
<xml_diff>
--- a/PPTs/20261030_L6.pptx
+++ b/PPTs/20261030_L6.pptx
@@ -132,21 +132,21 @@
   <p:extLst>
     <p:ext uri="{521415D9-36F7-43E2-AB2F-B90AF26B5E84}">
       <p14:sectionLst xmlns:p14="http://schemas.microsoft.com/office/powerpoint/2010/main">
-        <p14:section name="Intro" id="{80a010b3-258f-8cb9-c0b8-6537cbce5c5e}">
+        <p14:section name="Intro" id="{52aec715-59e0-7cbf-924c-d2047fe0537c}">
           <p14:sldIdLst>
             <p14:sldId id="256"/>
             <p14:sldId id="257"/>
             <p14:sldId id="258"/>
           </p14:sldIdLst>
         </p14:section>
-        <p14:section name="Files" id="{c939bf41-e04a-ac26-5274-c8ba8c68f556}">
+        <p14:section name="Files" id="{484c23c3-aaab-4b67-8b44-51e80b6b8fcd}">
           <p14:sldIdLst>
             <p14:sldId id="259"/>
             <p14:sldId id="260"/>
             <p14:sldId id="261"/>
           </p14:sldIdLst>
         </p14:section>
-        <p14:section name="Build" id="{0a8f72c8-4585-851a-e259-a1ca49a6cc1a}">
+        <p14:section name="Build" id="{2d3cd61c-772b-d6ea-4b1a-5a42505b8794}">
           <p14:sldIdLst>
             <p14:sldId id="262"/>
             <p14:sldId id="263"/>
@@ -156,7 +156,7 @@
             <p14:sldId id="267"/>
           </p14:sldIdLst>
         </p14:section>
-        <p14:section name="State" id="{510b9dad-7e65-7a86-ac3b-bc9ed5499abc}">
+        <p14:section name="State" id="{e14e652a-1173-09cb-af56-c71b793aa1f3}">
           <p14:sldIdLst>
             <p14:sldId id="268"/>
             <p14:sldId id="269"/>
@@ -166,20 +166,20 @@
             <p14:sldId id="273"/>
           </p14:sldIdLst>
         </p14:section>
-        <p14:section name="Debug" id="{f0ad6930-99a2-cbff-e51e-ba868099146a}">
+        <p14:section name="Debug" id="{62a48ee4-b37b-66f3-a5fd-308befd88b1b}">
           <p14:sldIdLst>
             <p14:sldId id="274"/>
             <p14:sldId id="275"/>
           </p14:sldIdLst>
         </p14:section>
-        <p14:section name="Meter" id="{d49ab6d5-1f81-4329-589d-1ed66aa6394f}">
+        <p14:section name="Meter" id="{c4d0fa15-a723-f4ab-8aba-987918af1c88}">
           <p14:sldIdLst>
             <p14:sldId id="276"/>
             <p14:sldId id="277"/>
             <p14:sldId id="278"/>
           </p14:sldIdLst>
         </p14:section>
-        <p14:section name="Close" id="{cb4016d9-4d5b-d2aa-49fe-0c4d7e311b59}">
+        <p14:section name="Close" id="{a3da5092-9896-a481-1cea-d591409ba33d}">
           <p14:sldIdLst>
             <p14:sldId id="279"/>
             <p14:sldId id="280"/>
@@ -25628,7 +25628,7 @@
                   <a:srgbClr val="0B3D2E"/>
                 </a:solidFill>
               </a:rPr>
-              <a:t>Wire it: a microphone, and the Lesson 3 LEDs</a:t>
+              <a:t>Wire it: microphone + Lesson 3 LEDs</a:t>
             </a:r>
             <a:endParaRPr lang="en-US" sz="3000" dirty="0"/>
           </a:p>
@@ -25813,7 +25813,7 @@
                   <a:srgbClr val="FFFFFF"/>
                 </a:solidFill>
               </a:rPr>
-              <a:t>GPIO36</a:t>
+              <a:t>SENSOR VP</a:t>
             </a:r>
             <a:endParaRPr lang="en-US" sz="1100" dirty="0"/>
           </a:p>
@@ -28831,7 +28831,7 @@
                   <a:srgbClr val="9A6B00"/>
                 </a:solidFill>
               </a:rPr>
-              <a:t>GPIO36 only.
+              <a:t>Only these pins today.
 </a:t>
             </a:r>
             <a:pPr indent="0" marL="0">
@@ -28843,7 +28843,7 @@
                   <a:srgbClr val="1B1B1B"/>
                 </a:solidFill>
               </a:rPr>
-              <a:t>GPIO25, 26 and 27 stop reading once Wi-Fi starts. 36 keeps working.</a:t>
+              <a:t>Leave the ultrasonic sensor, the buzzer and the servo in the box.</a:t>
             </a:r>
             <a:endParaRPr lang="en-US" sz="1200" dirty="0"/>
           </a:p>
@@ -28865,8 +28865,8 @@
         </p:blipFill>
         <p:spPr>
           <a:xfrm>
-            <a:off x="6035040" y="3429000"/>
-            <a:ext cx="877824" cy="1234440"/>
+            <a:off x="6035040" y="3291840"/>
+            <a:ext cx="941832" cy="1325880"/>
           </a:xfrm>
           <a:prstGeom prst="rect">
             <a:avLst/>
@@ -28881,8 +28881,8 @@
         </p:nvSpPr>
         <p:spPr>
           <a:xfrm>
-            <a:off x="7040880" y="3429000"/>
-            <a:ext cx="1691640" cy="1234440"/>
+            <a:off x="7086600" y="3383280"/>
+            <a:ext cx="1645920" cy="1097280"/>
           </a:xfrm>
           <a:prstGeom prst="rect">
             <a:avLst/>
@@ -28898,7 +28898,7 @@
               <a:buNone/>
             </a:pPr>
             <a:r>
-              <a:rPr lang="en-US" sz="1100" b="1" dirty="0">
+              <a:rPr lang="en-US" sz="1200" b="1" dirty="0">
                 <a:solidFill>
                   <a:srgbClr val="0B3D2E"/>
                 </a:solidFill>
@@ -28912,42 +28912,28 @@
               <a:buNone/>
             </a:pPr>
             <a:r>
-              <a:rPr lang="en-US" sz="1100" dirty="0">
+              <a:rPr lang="en-US" sz="1200" dirty="0">
                 <a:solidFill>
                   <a:srgbClr val="0B3D2E"/>
                 </a:solidFill>
               </a:rPr>
-              <a:t> in that order.</a:t>
-            </a:r>
-            <a:endParaRPr lang="en-US" sz="1100" dirty="0"/>
-          </a:p>
-          <a:p>
-            <a:pPr indent="0" marL="0">
-              <a:buNone/>
-            </a:pPr>
-            <a:r>
-              <a:rPr lang="en-US" sz="1100" dirty="0">
+              <a:t> in that order on the module.</a:t>
+            </a:r>
+            <a:endParaRPr lang="en-US" sz="1200" dirty="0"/>
+          </a:p>
+          <a:p>
+            <a:pPr indent="0" marL="0">
+              <a:buNone/>
+            </a:pPr>
+            <a:r>
+              <a:rPr lang="en-US" sz="1200" dirty="0">
                 <a:solidFill>
                   <a:srgbClr val="0B3D2E"/>
                 </a:solidFill>
               </a:rPr>
-              <a:t>V to 3V3, never 5V: GPIO36 must not see more than 3.3 V.</a:t>
-            </a:r>
-            <a:endParaRPr lang="en-US" sz="1100" dirty="0"/>
-          </a:p>
-          <a:p>
-            <a:pPr indent="0" marL="0">
-              <a:buNone/>
-            </a:pPr>
-            <a:r>
-              <a:rPr lang="en-US" sz="1100" dirty="0">
-                <a:solidFill>
-                  <a:srgbClr val="0B3D2E"/>
-                </a:solidFill>
-              </a:rPr>
-              <a:t>A quiet room sits near 0. Sound shows as spikes upward.</a:t>
-            </a:r>
-            <a:endParaRPr lang="en-US" sz="1100" dirty="0"/>
+              <a:t>SENSOR VP is the pin under EN.</a:t>
+            </a:r>
+            <a:endParaRPr lang="en-US" sz="1200" dirty="0"/>
           </a:p>
         </p:txBody>
       </p:sp>
@@ -29271,7 +29257,7 @@
               <a:buNone/>
             </a:pPr>
             <a:r>
-              <a:rPr lang="en-US" sz="900" dirty="0">
+              <a:rPr lang="en-US" sz="1000" dirty="0">
                 <a:solidFill>
                   <a:srgbClr val="6F8A7F"/>
                 </a:solidFill>
@@ -29285,7 +29271,7 @@
               <a:buNone/>
             </a:pPr>
             <a:r>
-              <a:rPr lang="en-US" sz="900" dirty="0">
+              <a:rPr lang="en-US" sz="1000" dirty="0">
                 <a:solidFill>
                   <a:srgbClr val="E6F2EC"/>
                 </a:solidFill>
@@ -29293,16 +29279,16 @@
                 <a:ea typeface="Courier New" pitchFamily="34" charset="-122"/>
                 <a:cs typeface="Courier New" pitchFamily="34" charset="-120"/>
               </a:rPr>
-              <a:t>mic = ADC(Pin(36))</a:t>
-            </a:r>
-            <a:endParaRPr lang="en-US" sz="900" dirty="0"/>
-          </a:p>
-          <a:p>
-            <a:pPr indent="0" marL="0">
-              <a:buNone/>
-            </a:pPr>
-            <a:r>
-              <a:rPr lang="en-US" sz="900" dirty="0">
+              <a:t>mic.width(ADC.WIDTH_12BIT)    # answer as 0 to 4095</a:t>
+            </a:r>
+            <a:endParaRPr lang="en-US" sz="1000" dirty="0"/>
+          </a:p>
+          <a:p>
+            <a:pPr indent="0" marL="0">
+              <a:buNone/>
+            </a:pPr>
+            <a:r>
+              <a:rPr lang="en-US" sz="1000" dirty="0">
                 <a:solidFill>
                   <a:srgbClr val="6F8A7F"/>
                 </a:solidFill>
@@ -29316,7 +29302,7 @@
               <a:buNone/>
             </a:pPr>
             <a:r>
-              <a:rPr lang="en-US" sz="900" dirty="0">
+              <a:rPr lang="en-US" sz="1000" dirty="0">
                 <a:solidFill>
                   <a:srgbClr val="E6F2EC"/>
                 </a:solidFill>
@@ -29324,16 +29310,16 @@
                 <a:ea typeface="Courier New" pitchFamily="34" charset="-122"/>
                 <a:cs typeface="Courier New" pitchFamily="34" charset="-120"/>
               </a:rPr>
-              <a:t>mic.atten(ADC.ATTN_11DB)      # read the full 0 to 3.3 V</a:t>
-            </a:r>
-            <a:endParaRPr lang="en-US" sz="900" dirty="0"/>
-          </a:p>
-          <a:p>
-            <a:pPr indent="0" marL="0">
-              <a:buNone/>
-            </a:pPr>
-            <a:r>
-              <a:rPr lang="en-US" sz="900" dirty="0">
+              <a:t> </a:t>
+            </a:r>
+            <a:endParaRPr lang="en-US" sz="1000" dirty="0"/>
+          </a:p>
+          <a:p>
+            <a:pPr indent="0" marL="0">
+              <a:buNone/>
+            </a:pPr>
+            <a:r>
+              <a:rPr lang="en-US" sz="1000" dirty="0">
                 <a:solidFill>
                   <a:srgbClr val="6F8A7F"/>
                 </a:solidFill>
@@ -29347,7 +29333,7 @@
               <a:buNone/>
             </a:pPr>
             <a:r>
-              <a:rPr lang="en-US" sz="900" dirty="0">
+              <a:rPr lang="en-US" sz="1000" dirty="0">
                 <a:solidFill>
                   <a:srgbClr val="E6F2EC"/>
                 </a:solidFill>
@@ -29355,16 +29341,16 @@
                 <a:ea typeface="Courier New" pitchFamily="34" charset="-122"/>
                 <a:cs typeface="Courier New" pitchFamily="34" charset="-120"/>
               </a:rPr>
-              <a:t>mic.width(ADC.WIDTH_12BIT)    # answer as 0 to 4095</a:t>
-            </a:r>
-            <a:endParaRPr lang="en-US" sz="900" dirty="0"/>
-          </a:p>
-          <a:p>
-            <a:pPr indent="0" marL="0">
-              <a:buNone/>
-            </a:pPr>
-            <a:r>
-              <a:rPr lang="en-US" sz="900" dirty="0">
+              <a:t>try:</a:t>
+            </a:r>
+            <a:endParaRPr lang="en-US" sz="1000" dirty="0"/>
+          </a:p>
+          <a:p>
+            <a:pPr indent="0" marL="0">
+              <a:buNone/>
+            </a:pPr>
+            <a:r>
+              <a:rPr lang="en-US" sz="1000" dirty="0">
                 <a:solidFill>
                   <a:srgbClr val="6F8A7F"/>
                 </a:solidFill>
@@ -29374,14 +29360,14 @@
               </a:rPr>
               <a:t>   ⋮</a:t>
             </a:r>
-            <a:endParaRPr lang="en-US" sz="900" dirty="0"/>
-          </a:p>
-          <a:p>
-            <a:pPr indent="0" marL="0">
-              <a:buNone/>
-            </a:pPr>
-            <a:r>
-              <a:rPr lang="en-US" sz="900" dirty="0">
+            <a:endParaRPr lang="en-US" sz="1000" dirty="0"/>
+          </a:p>
+          <a:p>
+            <a:pPr indent="0" marL="0">
+              <a:buNone/>
+            </a:pPr>
+            <a:r>
+              <a:rPr lang="en-US" sz="1000" dirty="0">
                 <a:solidFill>
                   <a:srgbClr val="6F8A7F"/>
                 </a:solidFill>
@@ -29395,7 +29381,7 @@
               <a:buNone/>
             </a:pPr>
             <a:r>
-              <a:rPr lang="en-US" sz="900" dirty="0">
+              <a:rPr lang="en-US" sz="1000" dirty="0">
                 <a:solidFill>
                   <a:srgbClr val="E6F2EC"/>
                 </a:solidFill>
@@ -29403,16 +29389,16 @@
                 <a:ea typeface="Courier New" pitchFamily="34" charset="-122"/>
                 <a:cs typeface="Courier New" pitchFamily="34" charset="-120"/>
               </a:rPr>
-              <a:t>    while True:</a:t>
-            </a:r>
-            <a:endParaRPr lang="en-US" sz="900" dirty="0"/>
-          </a:p>
-          <a:p>
-            <a:pPr indent="0" marL="0">
-              <a:buNone/>
-            </a:pPr>
-            <a:r>
-              <a:rPr lang="en-US" sz="900" dirty="0">
+              <a:t>        print(value)</a:t>
+            </a:r>
+            <a:endParaRPr lang="en-US" sz="1000" dirty="0"/>
+          </a:p>
+          <a:p>
+            <a:pPr indent="0" marL="0">
+              <a:buNone/>
+            </a:pPr>
+            <a:r>
+              <a:rPr lang="en-US" sz="1000" dirty="0">
                 <a:solidFill>
                   <a:srgbClr val="6F8A7F"/>
                 </a:solidFill>
@@ -29426,7 +29412,7 @@
               <a:buNone/>
             </a:pPr>
             <a:r>
-              <a:rPr lang="en-US" sz="900" dirty="0">
+              <a:rPr lang="en-US" sz="1000" dirty="0">
                 <a:solidFill>
                   <a:srgbClr val="E6F2EC"/>
                 </a:solidFill>
@@ -29434,16 +29420,16 @@
                 <a:ea typeface="Courier New" pitchFamily="34" charset="-122"/>
                 <a:cs typeface="Courier New" pitchFamily="34" charset="-120"/>
               </a:rPr>
-              <a:t>        value = mic.read()</a:t>
-            </a:r>
-            <a:endParaRPr lang="en-US" sz="900" dirty="0"/>
-          </a:p>
-          <a:p>
-            <a:pPr indent="0" marL="0">
-              <a:buNone/>
-            </a:pPr>
-            <a:r>
-              <a:rPr lang="en-US" sz="900" dirty="0">
+              <a:t>        time.sleep(0.2)</a:t>
+            </a:r>
+            <a:endParaRPr lang="en-US" sz="1000" dirty="0"/>
+          </a:p>
+          <a:p>
+            <a:pPr indent="0" marL="0">
+              <a:buNone/>
+            </a:pPr>
+            <a:r>
+              <a:rPr lang="en-US" sz="1000" dirty="0">
                 <a:solidFill>
                   <a:srgbClr val="6F8A7F"/>
                 </a:solidFill>
@@ -29457,7 +29443,7 @@
               <a:buNone/>
             </a:pPr>
             <a:r>
-              <a:rPr lang="en-US" sz="900" dirty="0">
+              <a:rPr lang="en-US" sz="1000" dirty="0">
                 <a:solidFill>
                   <a:srgbClr val="E6F2EC"/>
                 </a:solidFill>
@@ -29465,16 +29451,16 @@
                 <a:ea typeface="Courier New" pitchFamily="34" charset="-122"/>
                 <a:cs typeface="Courier New" pitchFamily="34" charset="-120"/>
               </a:rPr>
-              <a:t>        print(value)</a:t>
-            </a:r>
-            <a:endParaRPr lang="en-US" sz="900" dirty="0"/>
-          </a:p>
-          <a:p>
-            <a:pPr indent="0" marL="0">
-              <a:buNone/>
-            </a:pPr>
-            <a:r>
-              <a:rPr lang="en-US" sz="900" dirty="0">
+              <a:t> </a:t>
+            </a:r>
+            <a:endParaRPr lang="en-US" sz="1000" dirty="0"/>
+          </a:p>
+          <a:p>
+            <a:pPr indent="0" marL="0">
+              <a:buNone/>
+            </a:pPr>
+            <a:r>
+              <a:rPr lang="en-US" sz="1000" dirty="0">
                 <a:solidFill>
                   <a:srgbClr val="6F8A7F"/>
                 </a:solidFill>
@@ -29488,7 +29474,7 @@
               <a:buNone/>
             </a:pPr>
             <a:r>
-              <a:rPr lang="en-US" sz="900" dirty="0">
+              <a:rPr lang="en-US" sz="1000" dirty="0">
                 <a:solidFill>
                   <a:srgbClr val="E6F2EC"/>
                 </a:solidFill>
@@ -29496,9 +29482,9 @@
                 <a:ea typeface="Courier New" pitchFamily="34" charset="-122"/>
                 <a:cs typeface="Courier New" pitchFamily="34" charset="-120"/>
               </a:rPr>
-              <a:t>        time.sleep(0.2)</a:t>
-            </a:r>
-            <a:endParaRPr lang="en-US" sz="900" dirty="0"/>
+              <a:t>finally:</a:t>
+            </a:r>
+            <a:endParaRPr lang="en-US" sz="1000" dirty="0"/>
           </a:p>
         </p:txBody>
       </p:sp>
@@ -29644,7 +29630,7 @@
                   <a:srgbClr val="1B1B1B"/>
                 </a:solidFill>
               </a:rPr>
-              <a:t>Always 0? Check the S wire goes to GPIO36.</a:t>
+              <a:t>Always 0? S is on SENSOR VP, the pin under EN.</a:t>
             </a:r>
             <a:endParaRPr lang="en-US" sz="1400" dirty="0"/>
           </a:p>

</xml_diff>